<commit_message>
Add CRM to the roadmap slide
Roadmap now shows two NEXT horizons — CRM (leads, contacts, deal pipeline,
follow-ups, linked to invoices/statements) and Scale & go-live. Re-spaced the
slide to five cards with dynamic centering; subtitle updated.

Co-Authored-By: Claude Opus 4.8 <noreply@anthropic.com>
</commit_message>
<xml_diff>
--- a/BizClinik_ERP_Explainer_2026-06-05.pptx
+++ b/BizClinik_ERP_Explainer_2026-06-05.pptx
@@ -7768,7 +7768,7 @@
                 <a:ea typeface="Calibri Light" pitchFamily="34" charset="-122"/>
                 <a:cs typeface="Calibri Light" pitchFamily="34" charset="-120"/>
               </a:rPr>
-              <a:t>The original three-tier plan is complete. One foundational item remains, plus go-live inputs.</a:t>
+              <a:t>The original three-tier plan is complete. Next up: CRM, scale to Postgres, and billing go-live.</a:t>
             </a:r>
             <a:endParaRPr lang="en-US" sz="1300" dirty="0"/>
           </a:p>
@@ -7782,8 +7782,8 @@
         </p:nvSpPr>
         <p:spPr>
           <a:xfrm>
-            <a:off x="457200" y="2377440"/>
-            <a:ext cx="1965960" cy="2103120"/>
+            <a:off x="228600" y="2377440"/>
+            <a:ext cx="1627632" cy="2103120"/>
           </a:xfrm>
           <a:prstGeom prst="rect">
             <a:avLst/>
@@ -7814,8 +7814,8 @@
         </p:nvSpPr>
         <p:spPr>
           <a:xfrm>
-            <a:off x="457200" y="2377440"/>
-            <a:ext cx="1965960" cy="54864"/>
+            <a:off x="228600" y="2377440"/>
+            <a:ext cx="1627632" cy="54864"/>
           </a:xfrm>
           <a:prstGeom prst="rect">
             <a:avLst/>
@@ -7839,24 +7839,24 @@
         </p:nvSpPr>
         <p:spPr>
           <a:xfrm>
-            <a:off x="640080" y="2542032"/>
-            <a:ext cx="1691640" cy="274320"/>
-          </a:xfrm>
-          <a:prstGeom prst="rect">
-            <a:avLst/>
-          </a:prstGeom>
-          <a:noFill/>
-          <a:ln/>
-        </p:spPr>
-        <p:txBody>
-          <a:bodyPr wrap="square" lIns="0" tIns="0" rIns="0" bIns="0" rtlCol="0" anchor="ctr"/>
-          <a:lstStyle/>
-          <a:p>
-            <a:pPr indent="0" marL="0">
-              <a:buNone/>
-            </a:pPr>
-            <a:r>
-              <a:rPr lang="en-US" sz="1000" b="1" spc="300" kern="0" dirty="0">
+            <a:off x="374904" y="2523744"/>
+            <a:ext cx="1353312" cy="274320"/>
+          </a:xfrm>
+          <a:prstGeom prst="rect">
+            <a:avLst/>
+          </a:prstGeom>
+          <a:noFill/>
+          <a:ln/>
+        </p:spPr>
+        <p:txBody>
+          <a:bodyPr wrap="square" lIns="0" tIns="0" rIns="0" bIns="0" rtlCol="0" anchor="ctr"/>
+          <a:lstStyle/>
+          <a:p>
+            <a:pPr indent="0" marL="0">
+              <a:buNone/>
+            </a:pPr>
+            <a:r>
+              <a:rPr lang="en-US" sz="950" b="1" spc="200" kern="0" dirty="0">
                 <a:solidFill>
                   <a:srgbClr val="16A34A"/>
                 </a:solidFill>
@@ -7866,7 +7866,7 @@
               </a:rPr>
               <a:t>DELIVERED</a:t>
             </a:r>
-            <a:endParaRPr lang="en-US" sz="1000" dirty="0"/>
+            <a:endParaRPr lang="en-US" sz="950" dirty="0"/>
           </a:p>
         </p:txBody>
       </p:sp>
@@ -7878,24 +7878,24 @@
         </p:nvSpPr>
         <p:spPr>
           <a:xfrm>
-            <a:off x="640080" y="2788920"/>
-            <a:ext cx="1691640" cy="457200"/>
-          </a:xfrm>
-          <a:prstGeom prst="rect">
-            <a:avLst/>
-          </a:prstGeom>
-          <a:noFill/>
-          <a:ln/>
-        </p:spPr>
-        <p:txBody>
-          <a:bodyPr wrap="square" lIns="0" tIns="0" rIns="0" bIns="0" rtlCol="0" anchor="ctr"/>
-          <a:lstStyle/>
-          <a:p>
-            <a:pPr indent="0" marL="0">
-              <a:buNone/>
-            </a:pPr>
-            <a:r>
-              <a:rPr lang="en-US" sz="1500" b="1" dirty="0">
+            <a:off x="374904" y="2761488"/>
+            <a:ext cx="1353312" cy="457200"/>
+          </a:xfrm>
+          <a:prstGeom prst="rect">
+            <a:avLst/>
+          </a:prstGeom>
+          <a:noFill/>
+          <a:ln/>
+        </p:spPr>
+        <p:txBody>
+          <a:bodyPr wrap="square" lIns="0" tIns="0" rIns="0" bIns="0" rtlCol="0" anchor="ctr"/>
+          <a:lstStyle/>
+          <a:p>
+            <a:pPr indent="0" marL="0">
+              <a:buNone/>
+            </a:pPr>
+            <a:r>
+              <a:rPr lang="en-US" sz="1400" b="1" dirty="0">
                 <a:solidFill>
                   <a:srgbClr val="0F172A"/>
                 </a:solidFill>
@@ -7905,7 +7905,7 @@
               </a:rPr>
               <a:t>Trust the books</a:t>
             </a:r>
-            <a:endParaRPr lang="en-US" sz="1500" dirty="0"/>
+            <a:endParaRPr lang="en-US" sz="1400" dirty="0"/>
           </a:p>
         </p:txBody>
       </p:sp>
@@ -7917,24 +7917,24 @@
         </p:nvSpPr>
         <p:spPr>
           <a:xfrm>
-            <a:off x="640080" y="3246120"/>
-            <a:ext cx="1691640" cy="1143000"/>
-          </a:xfrm>
-          <a:prstGeom prst="rect">
-            <a:avLst/>
-          </a:prstGeom>
-          <a:noFill/>
-          <a:ln/>
-        </p:spPr>
-        <p:txBody>
-          <a:bodyPr wrap="square" lIns="0" tIns="0" rIns="0" bIns="0" rtlCol="0" anchor="ctr"/>
-          <a:lstStyle/>
-          <a:p>
-            <a:pPr indent="0" marL="0">
-              <a:buNone/>
-            </a:pPr>
-            <a:r>
-              <a:rPr lang="en-US" sz="1050" dirty="0">
+            <a:off x="374904" y="3218688"/>
+            <a:ext cx="1353312" cy="1188720"/>
+          </a:xfrm>
+          <a:prstGeom prst="rect">
+            <a:avLst/>
+          </a:prstGeom>
+          <a:noFill/>
+          <a:ln/>
+        </p:spPr>
+        <p:txBody>
+          <a:bodyPr wrap="square" lIns="0" tIns="0" rIns="0" bIns="0" rtlCol="0" anchor="ctr"/>
+          <a:lstStyle/>
+          <a:p>
+            <a:pPr indent="0" marL="0">
+              <a:buNone/>
+            </a:pPr>
+            <a:r>
+              <a:rPr lang="en-US" sz="1000" dirty="0">
                 <a:solidFill>
                   <a:srgbClr val="64748B"/>
                 </a:solidFill>
@@ -7942,9 +7942,9 @@
                 <a:ea typeface="Calibri Light" pitchFamily="34" charset="-122"/>
                 <a:cs typeface="Calibri Light" pitchFamily="34" charset="-120"/>
               </a:rPr>
-              <a:t>Audit trail, period close, void / reverse, real bank reconciliation.</a:t>
-            </a:r>
-            <a:endParaRPr lang="en-US" sz="1050" dirty="0"/>
+              <a:t>Audit trail, period close, void / reverse, bank reconciliation.</a:t>
+            </a:r>
+            <a:endParaRPr lang="en-US" sz="1000" dirty="0"/>
           </a:p>
         </p:txBody>
       </p:sp>
@@ -7956,8 +7956,8 @@
         </p:nvSpPr>
         <p:spPr>
           <a:xfrm>
-            <a:off x="2606040" y="2377440"/>
-            <a:ext cx="1965960" cy="2103120"/>
+            <a:off x="1993392" y="2377440"/>
+            <a:ext cx="1627632" cy="2103120"/>
           </a:xfrm>
           <a:prstGeom prst="rect">
             <a:avLst/>
@@ -7988,8 +7988,8 @@
         </p:nvSpPr>
         <p:spPr>
           <a:xfrm>
-            <a:off x="2606040" y="2377440"/>
-            <a:ext cx="1965960" cy="54864"/>
+            <a:off x="1993392" y="2377440"/>
+            <a:ext cx="1627632" cy="54864"/>
           </a:xfrm>
           <a:prstGeom prst="rect">
             <a:avLst/>
@@ -8013,24 +8013,24 @@
         </p:nvSpPr>
         <p:spPr>
           <a:xfrm>
-            <a:off x="2788920" y="2542032"/>
-            <a:ext cx="1691640" cy="274320"/>
-          </a:xfrm>
-          <a:prstGeom prst="rect">
-            <a:avLst/>
-          </a:prstGeom>
-          <a:noFill/>
-          <a:ln/>
-        </p:spPr>
-        <p:txBody>
-          <a:bodyPr wrap="square" lIns="0" tIns="0" rIns="0" bIns="0" rtlCol="0" anchor="ctr"/>
-          <a:lstStyle/>
-          <a:p>
-            <a:pPr indent="0" marL="0">
-              <a:buNone/>
-            </a:pPr>
-            <a:r>
-              <a:rPr lang="en-US" sz="1000" b="1" spc="300" kern="0" dirty="0">
+            <a:off x="2139696" y="2523744"/>
+            <a:ext cx="1353312" cy="274320"/>
+          </a:xfrm>
+          <a:prstGeom prst="rect">
+            <a:avLst/>
+          </a:prstGeom>
+          <a:noFill/>
+          <a:ln/>
+        </p:spPr>
+        <p:txBody>
+          <a:bodyPr wrap="square" lIns="0" tIns="0" rIns="0" bIns="0" rtlCol="0" anchor="ctr"/>
+          <a:lstStyle/>
+          <a:p>
+            <a:pPr indent="0" marL="0">
+              <a:buNone/>
+            </a:pPr>
+            <a:r>
+              <a:rPr lang="en-US" sz="950" b="1" spc="200" kern="0" dirty="0">
                 <a:solidFill>
                   <a:srgbClr val="16A34A"/>
                 </a:solidFill>
@@ -8040,7 +8040,7 @@
               </a:rPr>
               <a:t>DELIVERED</a:t>
             </a:r>
-            <a:endParaRPr lang="en-US" sz="1000" dirty="0"/>
+            <a:endParaRPr lang="en-US" sz="950" dirty="0"/>
           </a:p>
         </p:txBody>
       </p:sp>
@@ -8052,24 +8052,24 @@
         </p:nvSpPr>
         <p:spPr>
           <a:xfrm>
-            <a:off x="2788920" y="2788920"/>
-            <a:ext cx="1691640" cy="457200"/>
-          </a:xfrm>
-          <a:prstGeom prst="rect">
-            <a:avLst/>
-          </a:prstGeom>
-          <a:noFill/>
-          <a:ln/>
-        </p:spPr>
-        <p:txBody>
-          <a:bodyPr wrap="square" lIns="0" tIns="0" rIns="0" bIns="0" rtlCol="0" anchor="ctr"/>
-          <a:lstStyle/>
-          <a:p>
-            <a:pPr indent="0" marL="0">
-              <a:buNone/>
-            </a:pPr>
-            <a:r>
-              <a:rPr lang="en-US" sz="1500" b="1" dirty="0">
+            <a:off x="2139696" y="2761488"/>
+            <a:ext cx="1353312" cy="457200"/>
+          </a:xfrm>
+          <a:prstGeom prst="rect">
+            <a:avLst/>
+          </a:prstGeom>
+          <a:noFill/>
+          <a:ln/>
+        </p:spPr>
+        <p:txBody>
+          <a:bodyPr wrap="square" lIns="0" tIns="0" rIns="0" bIns="0" rtlCol="0" anchor="ctr"/>
+          <a:lstStyle/>
+          <a:p>
+            <a:pPr indent="0" marL="0">
+              <a:buNone/>
+            </a:pPr>
+            <a:r>
+              <a:rPr lang="en-US" sz="1400" b="1" dirty="0">
                 <a:solidFill>
                   <a:srgbClr val="0F172A"/>
                 </a:solidFill>
@@ -8079,7 +8079,7 @@
               </a:rPr>
               <a:t>Fit for Nigeria</a:t>
             </a:r>
-            <a:endParaRPr lang="en-US" sz="1500" dirty="0"/>
+            <a:endParaRPr lang="en-US" sz="1400" dirty="0"/>
           </a:p>
         </p:txBody>
       </p:sp>
@@ -8091,24 +8091,24 @@
         </p:nvSpPr>
         <p:spPr>
           <a:xfrm>
-            <a:off x="2788920" y="3246120"/>
-            <a:ext cx="1691640" cy="1143000"/>
-          </a:xfrm>
-          <a:prstGeom prst="rect">
-            <a:avLst/>
-          </a:prstGeom>
-          <a:noFill/>
-          <a:ln/>
-        </p:spPr>
-        <p:txBody>
-          <a:bodyPr wrap="square" lIns="0" tIns="0" rIns="0" bIns="0" rtlCol="0" anchor="ctr"/>
-          <a:lstStyle/>
-          <a:p>
-            <a:pPr indent="0" marL="0">
-              <a:buNone/>
-            </a:pPr>
-            <a:r>
-              <a:rPr lang="en-US" sz="1050" dirty="0">
+            <a:off x="2139696" y="3218688"/>
+            <a:ext cx="1353312" cy="1188720"/>
+          </a:xfrm>
+          <a:prstGeom prst="rect">
+            <a:avLst/>
+          </a:prstGeom>
+          <a:noFill/>
+          <a:ln/>
+        </p:spPr>
+        <p:txBody>
+          <a:bodyPr wrap="square" lIns="0" tIns="0" rIns="0" bIns="0" rtlCol="0" anchor="ctr"/>
+          <a:lstStyle/>
+          <a:p>
+            <a:pPr indent="0" marL="0">
+              <a:buNone/>
+            </a:pPr>
+            <a:r>
+              <a:rPr lang="en-US" sz="1000" dirty="0">
                 <a:solidFill>
                   <a:srgbClr val="64748B"/>
                 </a:solidFill>
@@ -8116,9 +8116,9 @@
                 <a:ea typeface="Calibri Light" pitchFamily="34" charset="-122"/>
                 <a:cs typeface="Calibri Light" pitchFamily="34" charset="-120"/>
               </a:rPr>
-              <a:t>Graduated PAYE, FIRS e-invoice, WHT, multi-bank statement imports.</a:t>
-            </a:r>
-            <a:endParaRPr lang="en-US" sz="1050" dirty="0"/>
+              <a:t>Graduated PAYE, FIRS e-invoice, WHT, multi-bank imports.</a:t>
+            </a:r>
+            <a:endParaRPr lang="en-US" sz="1000" dirty="0"/>
           </a:p>
         </p:txBody>
       </p:sp>
@@ -8130,8 +8130,8 @@
         </p:nvSpPr>
         <p:spPr>
           <a:xfrm>
-            <a:off x="4754880" y="2377440"/>
-            <a:ext cx="1965960" cy="2103120"/>
+            <a:off x="3758184" y="2377440"/>
+            <a:ext cx="1627632" cy="2103120"/>
           </a:xfrm>
           <a:prstGeom prst="rect">
             <a:avLst/>
@@ -8162,8 +8162,8 @@
         </p:nvSpPr>
         <p:spPr>
           <a:xfrm>
-            <a:off x="4754880" y="2377440"/>
-            <a:ext cx="1965960" cy="54864"/>
+            <a:off x="3758184" y="2377440"/>
+            <a:ext cx="1627632" cy="54864"/>
           </a:xfrm>
           <a:prstGeom prst="rect">
             <a:avLst/>
@@ -8187,24 +8187,24 @@
         </p:nvSpPr>
         <p:spPr>
           <a:xfrm>
-            <a:off x="4937760" y="2542032"/>
-            <a:ext cx="1691640" cy="274320"/>
-          </a:xfrm>
-          <a:prstGeom prst="rect">
-            <a:avLst/>
-          </a:prstGeom>
-          <a:noFill/>
-          <a:ln/>
-        </p:spPr>
-        <p:txBody>
-          <a:bodyPr wrap="square" lIns="0" tIns="0" rIns="0" bIns="0" rtlCol="0" anchor="ctr"/>
-          <a:lstStyle/>
-          <a:p>
-            <a:pPr indent="0" marL="0">
-              <a:buNone/>
-            </a:pPr>
-            <a:r>
-              <a:rPr lang="en-US" sz="1000" b="1" spc="300" kern="0" dirty="0">
+            <a:off x="3904488" y="2523744"/>
+            <a:ext cx="1353312" cy="274320"/>
+          </a:xfrm>
+          <a:prstGeom prst="rect">
+            <a:avLst/>
+          </a:prstGeom>
+          <a:noFill/>
+          <a:ln/>
+        </p:spPr>
+        <p:txBody>
+          <a:bodyPr wrap="square" lIns="0" tIns="0" rIns="0" bIns="0" rtlCol="0" anchor="ctr"/>
+          <a:lstStyle/>
+          <a:p>
+            <a:pPr indent="0" marL="0">
+              <a:buNone/>
+            </a:pPr>
+            <a:r>
+              <a:rPr lang="en-US" sz="950" b="1" spc="200" kern="0" dirty="0">
                 <a:solidFill>
                   <a:srgbClr val="16A34A"/>
                 </a:solidFill>
@@ -8214,7 +8214,7 @@
               </a:rPr>
               <a:t>DELIVERED</a:t>
             </a:r>
-            <a:endParaRPr lang="en-US" sz="1000" dirty="0"/>
+            <a:endParaRPr lang="en-US" sz="950" dirty="0"/>
           </a:p>
         </p:txBody>
       </p:sp>
@@ -8226,24 +8226,24 @@
         </p:nvSpPr>
         <p:spPr>
           <a:xfrm>
-            <a:off x="4937760" y="2788920"/>
-            <a:ext cx="1691640" cy="457200"/>
-          </a:xfrm>
-          <a:prstGeom prst="rect">
-            <a:avLst/>
-          </a:prstGeom>
-          <a:noFill/>
-          <a:ln/>
-        </p:spPr>
-        <p:txBody>
-          <a:bodyPr wrap="square" lIns="0" tIns="0" rIns="0" bIns="0" rtlCol="0" anchor="ctr"/>
-          <a:lstStyle/>
-          <a:p>
-            <a:pPr indent="0" marL="0">
-              <a:buNone/>
-            </a:pPr>
-            <a:r>
-              <a:rPr lang="en-US" sz="1500" b="1" dirty="0">
+            <a:off x="3904488" y="2761488"/>
+            <a:ext cx="1353312" cy="457200"/>
+          </a:xfrm>
+          <a:prstGeom prst="rect">
+            <a:avLst/>
+          </a:prstGeom>
+          <a:noFill/>
+          <a:ln/>
+        </p:spPr>
+        <p:txBody>
+          <a:bodyPr wrap="square" lIns="0" tIns="0" rIns="0" bIns="0" rtlCol="0" anchor="ctr"/>
+          <a:lstStyle/>
+          <a:p>
+            <a:pPr indent="0" marL="0">
+              <a:buNone/>
+            </a:pPr>
+            <a:r>
+              <a:rPr lang="en-US" sz="1400" b="1" dirty="0">
                 <a:solidFill>
                   <a:srgbClr val="0F172A"/>
                 </a:solidFill>
@@ -8253,7 +8253,7 @@
               </a:rPr>
               <a:t>Sell as SaaS</a:t>
             </a:r>
-            <a:endParaRPr lang="en-US" sz="1500" dirty="0"/>
+            <a:endParaRPr lang="en-US" sz="1400" dirty="0"/>
           </a:p>
         </p:txBody>
       </p:sp>
@@ -8265,24 +8265,24 @@
         </p:nvSpPr>
         <p:spPr>
           <a:xfrm>
-            <a:off x="4937760" y="3246120"/>
-            <a:ext cx="1691640" cy="1143000"/>
-          </a:xfrm>
-          <a:prstGeom prst="rect">
-            <a:avLst/>
-          </a:prstGeom>
-          <a:noFill/>
-          <a:ln/>
-        </p:spPr>
-        <p:txBody>
-          <a:bodyPr wrap="square" lIns="0" tIns="0" rIns="0" bIns="0" rtlCol="0" anchor="ctr"/>
-          <a:lstStyle/>
-          <a:p>
-            <a:pPr indent="0" marL="0">
-              <a:buNone/>
-            </a:pPr>
-            <a:r>
-              <a:rPr lang="en-US" sz="1050" dirty="0">
+            <a:off x="3904488" y="3218688"/>
+            <a:ext cx="1353312" cy="1188720"/>
+          </a:xfrm>
+          <a:prstGeom prst="rect">
+            <a:avLst/>
+          </a:prstGeom>
+          <a:noFill/>
+          <a:ln/>
+        </p:spPr>
+        <p:txBody>
+          <a:bodyPr wrap="square" lIns="0" tIns="0" rIns="0" bIns="0" rtlCol="0" anchor="ctr"/>
+          <a:lstStyle/>
+          <a:p>
+            <a:pPr indent="0" marL="0">
+              <a:buNone/>
+            </a:pPr>
+            <a:r>
+              <a:rPr lang="en-US" sz="1000" dirty="0">
                 <a:solidFill>
                   <a:srgbClr val="64748B"/>
                 </a:solidFill>
@@ -8290,9 +8290,9 @@
                 <a:ea typeface="Calibri Light" pitchFamily="34" charset="-122"/>
                 <a:cs typeface="Calibri Light" pitchFamily="34" charset="-120"/>
               </a:rPr>
-              <a:t>Multi-tenant, subdomains, billing, REST API, encrypted offsite backups, CI + uptime.</a:t>
-            </a:r>
-            <a:endParaRPr lang="en-US" sz="1050" dirty="0"/>
+              <a:t>Multi-tenant, subdomains, billing, API, offsite backups, CI.</a:t>
+            </a:r>
+            <a:endParaRPr lang="en-US" sz="1000" dirty="0"/>
           </a:p>
         </p:txBody>
       </p:sp>
@@ -8304,8 +8304,8 @@
         </p:nvSpPr>
         <p:spPr>
           <a:xfrm>
-            <a:off x="6903720" y="2377440"/>
-            <a:ext cx="1965960" cy="2103120"/>
+            <a:off x="5522976" y="2377440"/>
+            <a:ext cx="1627632" cy="2103120"/>
           </a:xfrm>
           <a:prstGeom prst="rect">
             <a:avLst/>
@@ -8336,8 +8336,8 @@
         </p:nvSpPr>
         <p:spPr>
           <a:xfrm>
-            <a:off x="6903720" y="2377440"/>
-            <a:ext cx="1965960" cy="54864"/>
+            <a:off x="5522976" y="2377440"/>
+            <a:ext cx="1627632" cy="54864"/>
           </a:xfrm>
           <a:prstGeom prst="rect">
             <a:avLst/>
@@ -8361,24 +8361,24 @@
         </p:nvSpPr>
         <p:spPr>
           <a:xfrm>
-            <a:off x="7086600" y="2542032"/>
-            <a:ext cx="1691640" cy="274320"/>
-          </a:xfrm>
-          <a:prstGeom prst="rect">
-            <a:avLst/>
-          </a:prstGeom>
-          <a:noFill/>
-          <a:ln/>
-        </p:spPr>
-        <p:txBody>
-          <a:bodyPr wrap="square" lIns="0" tIns="0" rIns="0" bIns="0" rtlCol="0" anchor="ctr"/>
-          <a:lstStyle/>
-          <a:p>
-            <a:pPr indent="0" marL="0">
-              <a:buNone/>
-            </a:pPr>
-            <a:r>
-              <a:rPr lang="en-US" sz="1000" b="1" spc="300" kern="0" dirty="0">
+            <a:off x="5669280" y="2523744"/>
+            <a:ext cx="1353312" cy="274320"/>
+          </a:xfrm>
+          <a:prstGeom prst="rect">
+            <a:avLst/>
+          </a:prstGeom>
+          <a:noFill/>
+          <a:ln/>
+        </p:spPr>
+        <p:txBody>
+          <a:bodyPr wrap="square" lIns="0" tIns="0" rIns="0" bIns="0" rtlCol="0" anchor="ctr"/>
+          <a:lstStyle/>
+          <a:p>
+            <a:pPr indent="0" marL="0">
+              <a:buNone/>
+            </a:pPr>
+            <a:r>
+              <a:rPr lang="en-US" sz="950" b="1" spc="200" kern="0" dirty="0">
                 <a:solidFill>
                   <a:srgbClr val="0EA5A4"/>
                 </a:solidFill>
@@ -8388,7 +8388,7 @@
               </a:rPr>
               <a:t>NEXT</a:t>
             </a:r>
-            <a:endParaRPr lang="en-US" sz="1000" dirty="0"/>
+            <a:endParaRPr lang="en-US" sz="950" dirty="0"/>
           </a:p>
         </p:txBody>
       </p:sp>
@@ -8400,24 +8400,24 @@
         </p:nvSpPr>
         <p:spPr>
           <a:xfrm>
-            <a:off x="7086600" y="2788920"/>
-            <a:ext cx="1691640" cy="457200"/>
-          </a:xfrm>
-          <a:prstGeom prst="rect">
-            <a:avLst/>
-          </a:prstGeom>
-          <a:noFill/>
-          <a:ln/>
-        </p:spPr>
-        <p:txBody>
-          <a:bodyPr wrap="square" lIns="0" tIns="0" rIns="0" bIns="0" rtlCol="0" anchor="ctr"/>
-          <a:lstStyle/>
-          <a:p>
-            <a:pPr indent="0" marL="0">
-              <a:buNone/>
-            </a:pPr>
-            <a:r>
-              <a:rPr lang="en-US" sz="1500" b="1" dirty="0">
+            <a:off x="5669280" y="2761488"/>
+            <a:ext cx="1353312" cy="457200"/>
+          </a:xfrm>
+          <a:prstGeom prst="rect">
+            <a:avLst/>
+          </a:prstGeom>
+          <a:noFill/>
+          <a:ln/>
+        </p:spPr>
+        <p:txBody>
+          <a:bodyPr wrap="square" lIns="0" tIns="0" rIns="0" bIns="0" rtlCol="0" anchor="ctr"/>
+          <a:lstStyle/>
+          <a:p>
+            <a:pPr indent="0" marL="0">
+              <a:buNone/>
+            </a:pPr>
+            <a:r>
+              <a:rPr lang="en-US" sz="1400" b="1" dirty="0">
                 <a:solidFill>
                   <a:srgbClr val="0F172A"/>
                 </a:solidFill>
@@ -8425,9 +8425,9 @@
                 <a:ea typeface="Calibri" pitchFamily="34" charset="-122"/>
                 <a:cs typeface="Calibri" pitchFamily="34" charset="-120"/>
               </a:rPr>
-              <a:t>Scale &amp; go-live</a:t>
-            </a:r>
-            <a:endParaRPr lang="en-US" sz="1500" dirty="0"/>
+              <a:t>CRM</a:t>
+            </a:r>
+            <a:endParaRPr lang="en-US" sz="1400" dirty="0"/>
           </a:p>
         </p:txBody>
       </p:sp>
@@ -8439,24 +8439,24 @@
         </p:nvSpPr>
         <p:spPr>
           <a:xfrm>
-            <a:off x="7086600" y="3246120"/>
-            <a:ext cx="1691640" cy="1143000"/>
-          </a:xfrm>
-          <a:prstGeom prst="rect">
-            <a:avLst/>
-          </a:prstGeom>
-          <a:noFill/>
-          <a:ln/>
-        </p:spPr>
-        <p:txBody>
-          <a:bodyPr wrap="square" lIns="0" tIns="0" rIns="0" bIns="0" rtlCol="0" anchor="ctr"/>
-          <a:lstStyle/>
-          <a:p>
-            <a:pPr indent="0" marL="0">
-              <a:buNone/>
-            </a:pPr>
-            <a:r>
-              <a:rPr lang="en-US" sz="1050" dirty="0">
+            <a:off x="5669280" y="3218688"/>
+            <a:ext cx="1353312" cy="1188720"/>
+          </a:xfrm>
+          <a:prstGeom prst="rect">
+            <a:avLst/>
+          </a:prstGeom>
+          <a:noFill/>
+          <a:ln/>
+        </p:spPr>
+        <p:txBody>
+          <a:bodyPr wrap="square" lIns="0" tIns="0" rIns="0" bIns="0" rtlCol="0" anchor="ctr"/>
+          <a:lstStyle/>
+          <a:p>
+            <a:pPr indent="0" marL="0">
+              <a:buNone/>
+            </a:pPr>
+            <a:r>
+              <a:rPr lang="en-US" sz="1000" dirty="0">
                 <a:solidFill>
                   <a:srgbClr val="64748B"/>
                 </a:solidFill>
@@ -8464,15 +8464,189 @@
                 <a:ea typeface="Calibri Light" pitchFamily="34" charset="-122"/>
                 <a:cs typeface="Calibri Light" pitchFamily="34" charset="-120"/>
               </a:rPr>
-              <a:t>Postgres for concurrency; billing go-live (provider keys); open-banking auto-feeds.</a:t>
-            </a:r>
-            <a:endParaRPr lang="en-US" sz="1050" dirty="0"/>
-          </a:p>
-        </p:txBody>
-      </p:sp>
-      <p:sp>
-        <p:nvSpPr>
-          <p:cNvPr id="29" name="Text 27"/>
+              <a:t>Leads, contacts, deal pipeline &amp; follow-up reminders — linked to invoices and statements.</a:t>
+            </a:r>
+            <a:endParaRPr lang="en-US" sz="1000" dirty="0"/>
+          </a:p>
+        </p:txBody>
+      </p:sp>
+      <p:sp>
+        <p:nvSpPr>
+          <p:cNvPr id="29" name="Shape 27"/>
+          <p:cNvSpPr/>
+          <p:nvPr/>
+        </p:nvSpPr>
+        <p:spPr>
+          <a:xfrm>
+            <a:off x="7287768" y="2377440"/>
+            <a:ext cx="1627632" cy="2103120"/>
+          </a:xfrm>
+          <a:prstGeom prst="rect">
+            <a:avLst/>
+          </a:prstGeom>
+          <a:solidFill>
+            <a:srgbClr val="FFFFFF"/>
+          </a:solidFill>
+          <a:ln w="6350">
+            <a:solidFill>
+              <a:srgbClr val="E5E7EB"/>
+            </a:solidFill>
+            <a:prstDash val="solid"/>
+          </a:ln>
+          <a:effectLst>
+            <a:outerShdw sx="100000" sy="100000" kx="0" ky="0" algn="bl" rotWithShape="0" blurRad="76200" dist="25400" dir="5400000">
+              <a:srgbClr val="1F3864">
+                <a:alpha val="5000"/>
+              </a:srgbClr>
+            </a:outerShdw>
+          </a:effectLst>
+        </p:spPr>
+      </p:sp>
+      <p:sp>
+        <p:nvSpPr>
+          <p:cNvPr id="30" name="Shape 28"/>
+          <p:cNvSpPr/>
+          <p:nvPr/>
+        </p:nvSpPr>
+        <p:spPr>
+          <a:xfrm>
+            <a:off x="7287768" y="2377440"/>
+            <a:ext cx="1627632" cy="54864"/>
+          </a:xfrm>
+          <a:prstGeom prst="rect">
+            <a:avLst/>
+          </a:prstGeom>
+          <a:solidFill>
+            <a:srgbClr val="0EA5A4"/>
+          </a:solidFill>
+          <a:ln w="12700">
+            <a:solidFill>
+              <a:srgbClr val="0EA5A4"/>
+            </a:solidFill>
+            <a:prstDash val="solid"/>
+          </a:ln>
+        </p:spPr>
+      </p:sp>
+      <p:sp>
+        <p:nvSpPr>
+          <p:cNvPr id="31" name="Text 29"/>
+          <p:cNvSpPr/>
+          <p:nvPr/>
+        </p:nvSpPr>
+        <p:spPr>
+          <a:xfrm>
+            <a:off x="7434072" y="2523744"/>
+            <a:ext cx="1353312" cy="274320"/>
+          </a:xfrm>
+          <a:prstGeom prst="rect">
+            <a:avLst/>
+          </a:prstGeom>
+          <a:noFill/>
+          <a:ln/>
+        </p:spPr>
+        <p:txBody>
+          <a:bodyPr wrap="square" lIns="0" tIns="0" rIns="0" bIns="0" rtlCol="0" anchor="ctr"/>
+          <a:lstStyle/>
+          <a:p>
+            <a:pPr indent="0" marL="0">
+              <a:buNone/>
+            </a:pPr>
+            <a:r>
+              <a:rPr lang="en-US" sz="950" b="1" spc="200" kern="0" dirty="0">
+                <a:solidFill>
+                  <a:srgbClr val="0EA5A4"/>
+                </a:solidFill>
+                <a:latin typeface="Calibri" pitchFamily="34" charset="0"/>
+                <a:ea typeface="Calibri" pitchFamily="34" charset="-122"/>
+                <a:cs typeface="Calibri" pitchFamily="34" charset="-120"/>
+              </a:rPr>
+              <a:t>NEXT</a:t>
+            </a:r>
+            <a:endParaRPr lang="en-US" sz="950" dirty="0"/>
+          </a:p>
+        </p:txBody>
+      </p:sp>
+      <p:sp>
+        <p:nvSpPr>
+          <p:cNvPr id="32" name="Text 30"/>
+          <p:cNvSpPr/>
+          <p:nvPr/>
+        </p:nvSpPr>
+        <p:spPr>
+          <a:xfrm>
+            <a:off x="7434072" y="2761488"/>
+            <a:ext cx="1353312" cy="457200"/>
+          </a:xfrm>
+          <a:prstGeom prst="rect">
+            <a:avLst/>
+          </a:prstGeom>
+          <a:noFill/>
+          <a:ln/>
+        </p:spPr>
+        <p:txBody>
+          <a:bodyPr wrap="square" lIns="0" tIns="0" rIns="0" bIns="0" rtlCol="0" anchor="ctr"/>
+          <a:lstStyle/>
+          <a:p>
+            <a:pPr indent="0" marL="0">
+              <a:buNone/>
+            </a:pPr>
+            <a:r>
+              <a:rPr lang="en-US" sz="1400" b="1" dirty="0">
+                <a:solidFill>
+                  <a:srgbClr val="0F172A"/>
+                </a:solidFill>
+                <a:latin typeface="Calibri" pitchFamily="34" charset="0"/>
+                <a:ea typeface="Calibri" pitchFamily="34" charset="-122"/>
+                <a:cs typeface="Calibri" pitchFamily="34" charset="-120"/>
+              </a:rPr>
+              <a:t>Scale &amp; go-live</a:t>
+            </a:r>
+            <a:endParaRPr lang="en-US" sz="1400" dirty="0"/>
+          </a:p>
+        </p:txBody>
+      </p:sp>
+      <p:sp>
+        <p:nvSpPr>
+          <p:cNvPr id="33" name="Text 31"/>
+          <p:cNvSpPr/>
+          <p:nvPr/>
+        </p:nvSpPr>
+        <p:spPr>
+          <a:xfrm>
+            <a:off x="7434072" y="3218688"/>
+            <a:ext cx="1353312" cy="1188720"/>
+          </a:xfrm>
+          <a:prstGeom prst="rect">
+            <a:avLst/>
+          </a:prstGeom>
+          <a:noFill/>
+          <a:ln/>
+        </p:spPr>
+        <p:txBody>
+          <a:bodyPr wrap="square" lIns="0" tIns="0" rIns="0" bIns="0" rtlCol="0" anchor="ctr"/>
+          <a:lstStyle/>
+          <a:p>
+            <a:pPr indent="0" marL="0">
+              <a:buNone/>
+            </a:pPr>
+            <a:r>
+              <a:rPr lang="en-US" sz="1000" dirty="0">
+                <a:solidFill>
+                  <a:srgbClr val="64748B"/>
+                </a:solidFill>
+                <a:latin typeface="Calibri Light" pitchFamily="34" charset="0"/>
+                <a:ea typeface="Calibri Light" pitchFamily="34" charset="-122"/>
+                <a:cs typeface="Calibri Light" pitchFamily="34" charset="-120"/>
+              </a:rPr>
+              <a:t>Postgres for concurrency; billing keys; open-banking auto-feeds.</a:t>
+            </a:r>
+            <a:endParaRPr lang="en-US" sz="1000" dirty="0"/>
+          </a:p>
+        </p:txBody>
+      </p:sp>
+      <p:sp>
+        <p:nvSpPr>
+          <p:cNvPr id="34" name="Text 32"/>
           <p:cNvSpPr/>
           <p:nvPr/>
         </p:nvSpPr>

</xml_diff>

<commit_message>
Deck: CRM is shipped — add to Platform Today, mark Delivered on roadmap
- Platform Today: 7th capability card (CRM); reflowed to a centered 4-col grid.
- Roadmap: CRM moved from NEXT to DELIVERED (4 delivered + 1 next: scale/go-live).

Co-Authored-By: Claude Opus 4.8 <noreply@anthropic.com>
</commit_message>
<xml_diff>
--- a/BizClinik_ERP_Explainer_2026-06-05.pptx
+++ b/BizClinik_ERP_Explainer_2026-06-05.pptx
@@ -6272,8 +6272,8 @@
         </p:nvSpPr>
         <p:spPr>
           <a:xfrm>
-            <a:off x="320040" y="2240280"/>
-            <a:ext cx="2743200" cy="1143000"/>
+            <a:off x="292608" y="2194560"/>
+            <a:ext cx="2057400" cy="1097280"/>
           </a:xfrm>
           <a:prstGeom prst="rect">
             <a:avLst/>
@@ -6304,8 +6304,8 @@
         </p:nvSpPr>
         <p:spPr>
           <a:xfrm>
-            <a:off x="320040" y="2240280"/>
-            <a:ext cx="73152" cy="1143000"/>
+            <a:off x="292608" y="2194560"/>
+            <a:ext cx="73152" cy="1097280"/>
           </a:xfrm>
           <a:prstGeom prst="rect">
             <a:avLst/>
@@ -6329,7 +6329,7 @@
         </p:nvSpPr>
         <p:spPr>
           <a:xfrm>
-            <a:off x="548640" y="2441448"/>
+            <a:off x="521208" y="2395728"/>
             <a:ext cx="502920" cy="502920"/>
           </a:xfrm>
           <a:prstGeom prst="ellipse">
@@ -6354,7 +6354,7 @@
         </p:nvSpPr>
         <p:spPr>
           <a:xfrm>
-            <a:off x="548640" y="2441448"/>
+            <a:off x="521208" y="2395728"/>
             <a:ext cx="502920" cy="502920"/>
           </a:xfrm>
           <a:prstGeom prst="rect">
@@ -6393,8 +6393,8 @@
         </p:nvSpPr>
         <p:spPr>
           <a:xfrm>
-            <a:off x="1188720" y="2404872"/>
-            <a:ext cx="1828800" cy="320040"/>
+            <a:off x="1161288" y="2359152"/>
+            <a:ext cx="1143000" cy="320040"/>
           </a:xfrm>
           <a:prstGeom prst="rect">
             <a:avLst/>
@@ -6432,8 +6432,8 @@
         </p:nvSpPr>
         <p:spPr>
           <a:xfrm>
-            <a:off x="1188720" y="2697480"/>
-            <a:ext cx="1783080" cy="640080"/>
+            <a:off x="1161288" y="2651760"/>
+            <a:ext cx="1097280" cy="594360"/>
           </a:xfrm>
           <a:prstGeom prst="rect">
             <a:avLst/>
@@ -6457,7 +6457,7 @@
                 <a:ea typeface="Calibri Light" pitchFamily="34" charset="-122"/>
                 <a:cs typeface="Calibri Light" pitchFamily="34" charset="-120"/>
               </a:rPr>
-              <a:t>Audit trail, fiscal period close, void / reverse, fixed-asset depreciation.</a:t>
+              <a:t>Audit trail, period close, void / reverse, fixed-asset depreciation.</a:t>
             </a:r>
             <a:endParaRPr lang="en-US" sz="1050" dirty="0"/>
           </a:p>
@@ -6471,8 +6471,8 @@
         </p:nvSpPr>
         <p:spPr>
           <a:xfrm>
-            <a:off x="3200400" y="2240280"/>
-            <a:ext cx="2743200" cy="1143000"/>
+            <a:off x="2459736" y="2194560"/>
+            <a:ext cx="2057400" cy="1097280"/>
           </a:xfrm>
           <a:prstGeom prst="rect">
             <a:avLst/>
@@ -6503,8 +6503,8 @@
         </p:nvSpPr>
         <p:spPr>
           <a:xfrm>
-            <a:off x="3200400" y="2240280"/>
-            <a:ext cx="73152" cy="1143000"/>
+            <a:off x="2459736" y="2194560"/>
+            <a:ext cx="73152" cy="1097280"/>
           </a:xfrm>
           <a:prstGeom prst="rect">
             <a:avLst/>
@@ -6528,7 +6528,7 @@
         </p:nvSpPr>
         <p:spPr>
           <a:xfrm>
-            <a:off x="3429000" y="2441448"/>
+            <a:off x="2688336" y="2395728"/>
             <a:ext cx="502920" cy="502920"/>
           </a:xfrm>
           <a:prstGeom prst="ellipse">
@@ -6553,7 +6553,7 @@
         </p:nvSpPr>
         <p:spPr>
           <a:xfrm>
-            <a:off x="3429000" y="2441448"/>
+            <a:off x="2688336" y="2395728"/>
             <a:ext cx="502920" cy="502920"/>
           </a:xfrm>
           <a:prstGeom prst="rect">
@@ -6592,8 +6592,8 @@
         </p:nvSpPr>
         <p:spPr>
           <a:xfrm>
-            <a:off x="4069080" y="2404872"/>
-            <a:ext cx="1828800" cy="320040"/>
+            <a:off x="3328416" y="2359152"/>
+            <a:ext cx="1143000" cy="320040"/>
           </a:xfrm>
           <a:prstGeom prst="rect">
             <a:avLst/>
@@ -6631,8 +6631,8 @@
         </p:nvSpPr>
         <p:spPr>
           <a:xfrm>
-            <a:off x="4069080" y="2697480"/>
-            <a:ext cx="1783080" cy="640080"/>
+            <a:off x="3328416" y="2651760"/>
+            <a:ext cx="1097280" cy="594360"/>
           </a:xfrm>
           <a:prstGeom prst="rect">
             <a:avLst/>
@@ -6670,8 +6670,8 @@
         </p:nvSpPr>
         <p:spPr>
           <a:xfrm>
-            <a:off x="6080760" y="2240280"/>
-            <a:ext cx="2743200" cy="1143000"/>
+            <a:off x="4626864" y="2194560"/>
+            <a:ext cx="2057400" cy="1097280"/>
           </a:xfrm>
           <a:prstGeom prst="rect">
             <a:avLst/>
@@ -6702,8 +6702,8 @@
         </p:nvSpPr>
         <p:spPr>
           <a:xfrm>
-            <a:off x="6080760" y="2240280"/>
-            <a:ext cx="73152" cy="1143000"/>
+            <a:off x="4626864" y="2194560"/>
+            <a:ext cx="73152" cy="1097280"/>
           </a:xfrm>
           <a:prstGeom prst="rect">
             <a:avLst/>
@@ -6727,7 +6727,7 @@
         </p:nvSpPr>
         <p:spPr>
           <a:xfrm>
-            <a:off x="6309360" y="2441448"/>
+            <a:off x="4855464" y="2395728"/>
             <a:ext cx="502920" cy="502920"/>
           </a:xfrm>
           <a:prstGeom prst="ellipse">
@@ -6752,7 +6752,7 @@
         </p:nvSpPr>
         <p:spPr>
           <a:xfrm>
-            <a:off x="6309360" y="2441448"/>
+            <a:off x="4855464" y="2395728"/>
             <a:ext cx="502920" cy="502920"/>
           </a:xfrm>
           <a:prstGeom prst="rect">
@@ -6791,8 +6791,8 @@
         </p:nvSpPr>
         <p:spPr>
           <a:xfrm>
-            <a:off x="6949440" y="2404872"/>
-            <a:ext cx="1828800" cy="320040"/>
+            <a:off x="5495544" y="2359152"/>
+            <a:ext cx="1143000" cy="320040"/>
           </a:xfrm>
           <a:prstGeom prst="rect">
             <a:avLst/>
@@ -6830,8 +6830,8 @@
         </p:nvSpPr>
         <p:spPr>
           <a:xfrm>
-            <a:off x="6949440" y="2697480"/>
-            <a:ext cx="1783080" cy="640080"/>
+            <a:off x="5495544" y="2651760"/>
+            <a:ext cx="1097280" cy="594360"/>
           </a:xfrm>
           <a:prstGeom prst="rect">
             <a:avLst/>
@@ -6855,7 +6855,7 @@
                 <a:ea typeface="Calibri Light" pitchFamily="34" charset="-122"/>
                 <a:cs typeface="Calibri Light" pitchFamily="34" charset="-120"/>
               </a:rPr>
-              <a:t>Multi-bank CSV (GTB / Access / Zenith / FBN / Moniepoint) + push-in bank feed, auto-match.</a:t>
+              <a:t>Multi-bank CSV + push-in bank feed, auto-matched to the GL.</a:t>
             </a:r>
             <a:endParaRPr lang="en-US" sz="1050" dirty="0"/>
           </a:p>
@@ -6869,8 +6869,8 @@
         </p:nvSpPr>
         <p:spPr>
           <a:xfrm>
-            <a:off x="320040" y="3566160"/>
-            <a:ext cx="2743200" cy="1143000"/>
+            <a:off x="6793992" y="2194560"/>
+            <a:ext cx="2057400" cy="1097280"/>
           </a:xfrm>
           <a:prstGeom prst="rect">
             <a:avLst/>
@@ -6901,8 +6901,8 @@
         </p:nvSpPr>
         <p:spPr>
           <a:xfrm>
-            <a:off x="320040" y="3566160"/>
-            <a:ext cx="73152" cy="1143000"/>
+            <a:off x="6793992" y="2194560"/>
+            <a:ext cx="73152" cy="1097280"/>
           </a:xfrm>
           <a:prstGeom prst="rect">
             <a:avLst/>
@@ -6926,7 +6926,7 @@
         </p:nvSpPr>
         <p:spPr>
           <a:xfrm>
-            <a:off x="548640" y="3767328"/>
+            <a:off x="7022592" y="2395728"/>
             <a:ext cx="502920" cy="502920"/>
           </a:xfrm>
           <a:prstGeom prst="ellipse">
@@ -6951,7 +6951,7 @@
         </p:nvSpPr>
         <p:spPr>
           <a:xfrm>
-            <a:off x="548640" y="3767328"/>
+            <a:off x="7022592" y="2395728"/>
             <a:ext cx="502920" cy="502920"/>
           </a:xfrm>
           <a:prstGeom prst="rect">
@@ -6990,8 +6990,8 @@
         </p:nvSpPr>
         <p:spPr>
           <a:xfrm>
-            <a:off x="1188720" y="3730752"/>
-            <a:ext cx="1828800" cy="320040"/>
+            <a:off x="7662672" y="2359152"/>
+            <a:ext cx="1143000" cy="320040"/>
           </a:xfrm>
           <a:prstGeom prst="rect">
             <a:avLst/>
@@ -7029,8 +7029,8 @@
         </p:nvSpPr>
         <p:spPr>
           <a:xfrm>
-            <a:off x="1188720" y="4023360"/>
-            <a:ext cx="1783080" cy="640080"/>
+            <a:off x="7662672" y="2651760"/>
+            <a:ext cx="1097280" cy="594360"/>
           </a:xfrm>
           <a:prstGeom prst="rect">
             <a:avLst/>
@@ -7054,7 +7054,7 @@
                 <a:ea typeface="Calibri Light" pitchFamily="34" charset="-122"/>
                 <a:cs typeface="Calibri Light" pitchFamily="34" charset="-120"/>
               </a:rPr>
-              <a:t>Isolated per-tenant databases, per-business subdomains, per-tenant invoice branding.</a:t>
+              <a:t>Isolated per-tenant DBs, subdomains, per-tenant invoice branding.</a:t>
             </a:r>
             <a:endParaRPr lang="en-US" sz="1050" dirty="0"/>
           </a:p>
@@ -7068,8 +7068,8 @@
         </p:nvSpPr>
         <p:spPr>
           <a:xfrm>
-            <a:off x="3200400" y="3566160"/>
-            <a:ext cx="2743200" cy="1143000"/>
+            <a:off x="1376172" y="3493008"/>
+            <a:ext cx="2057400" cy="1097280"/>
           </a:xfrm>
           <a:prstGeom prst="rect">
             <a:avLst/>
@@ -7100,8 +7100,8 @@
         </p:nvSpPr>
         <p:spPr>
           <a:xfrm>
-            <a:off x="3200400" y="3566160"/>
-            <a:ext cx="73152" cy="1143000"/>
+            <a:off x="1376172" y="3493008"/>
+            <a:ext cx="73152" cy="1097280"/>
           </a:xfrm>
           <a:prstGeom prst="rect">
             <a:avLst/>
@@ -7125,7 +7125,7 @@
         </p:nvSpPr>
         <p:spPr>
           <a:xfrm>
-            <a:off x="3429000" y="3767328"/>
+            <a:off x="1604772" y="3694176"/>
             <a:ext cx="502920" cy="502920"/>
           </a:xfrm>
           <a:prstGeom prst="ellipse">
@@ -7150,7 +7150,7 @@
         </p:nvSpPr>
         <p:spPr>
           <a:xfrm>
-            <a:off x="3429000" y="3767328"/>
+            <a:off x="1604772" y="3694176"/>
             <a:ext cx="502920" cy="502920"/>
           </a:xfrm>
           <a:prstGeom prst="rect">
@@ -7189,8 +7189,8 @@
         </p:nvSpPr>
         <p:spPr>
           <a:xfrm>
-            <a:off x="4069080" y="3730752"/>
-            <a:ext cx="1828800" cy="320040"/>
+            <a:off x="2244852" y="3657600"/>
+            <a:ext cx="1143000" cy="320040"/>
           </a:xfrm>
           <a:prstGeom prst="rect">
             <a:avLst/>
@@ -7228,8 +7228,8 @@
         </p:nvSpPr>
         <p:spPr>
           <a:xfrm>
-            <a:off x="4069080" y="4023360"/>
-            <a:ext cx="1783080" cy="640080"/>
+            <a:off x="2244852" y="3950208"/>
+            <a:ext cx="1097280" cy="594360"/>
           </a:xfrm>
           <a:prstGeom prst="rect">
             <a:avLst/>
@@ -7253,7 +7253,7 @@
                 <a:ea typeface="Calibri Light" pitchFamily="34" charset="-122"/>
                 <a:cs typeface="Calibri Light" pitchFamily="34" charset="-120"/>
               </a:rPr>
-              <a:t>Foreign-denominated invoices &amp; bills; realized + unrealized FX revaluation.</a:t>
+              <a:t>Foreign invoices &amp; bills; realized + unrealized FX revaluation.</a:t>
             </a:r>
             <a:endParaRPr lang="en-US" sz="1050" dirty="0"/>
           </a:p>
@@ -7267,8 +7267,8 @@
         </p:nvSpPr>
         <p:spPr>
           <a:xfrm>
-            <a:off x="6080760" y="3566160"/>
-            <a:ext cx="2743200" cy="1143000"/>
+            <a:off x="3543300" y="3493008"/>
+            <a:ext cx="2057400" cy="1097280"/>
           </a:xfrm>
           <a:prstGeom prst="rect">
             <a:avLst/>
@@ -7299,8 +7299,8 @@
         </p:nvSpPr>
         <p:spPr>
           <a:xfrm>
-            <a:off x="6080760" y="3566160"/>
-            <a:ext cx="73152" cy="1143000"/>
+            <a:off x="3543300" y="3493008"/>
+            <a:ext cx="73152" cy="1097280"/>
           </a:xfrm>
           <a:prstGeom prst="rect">
             <a:avLst/>
@@ -7324,7 +7324,7 @@
         </p:nvSpPr>
         <p:spPr>
           <a:xfrm>
-            <a:off x="6309360" y="3767328"/>
+            <a:off x="3771900" y="3694176"/>
             <a:ext cx="502920" cy="502920"/>
           </a:xfrm>
           <a:prstGeom prst="ellipse">
@@ -7349,7 +7349,7 @@
         </p:nvSpPr>
         <p:spPr>
           <a:xfrm>
-            <a:off x="6309360" y="3767328"/>
+            <a:off x="3771900" y="3694176"/>
             <a:ext cx="502920" cy="502920"/>
           </a:xfrm>
           <a:prstGeom prst="rect">
@@ -7388,8 +7388,8 @@
         </p:nvSpPr>
         <p:spPr>
           <a:xfrm>
-            <a:off x="6949440" y="3730752"/>
-            <a:ext cx="1828800" cy="320040"/>
+            <a:off x="4411980" y="3657600"/>
+            <a:ext cx="1143000" cy="320040"/>
           </a:xfrm>
           <a:prstGeom prst="rect">
             <a:avLst/>
@@ -7427,8 +7427,8 @@
         </p:nvSpPr>
         <p:spPr>
           <a:xfrm>
-            <a:off x="6949440" y="4023360"/>
-            <a:ext cx="1783080" cy="640080"/>
+            <a:off x="4411980" y="3950208"/>
+            <a:ext cx="1097280" cy="594360"/>
           </a:xfrm>
           <a:prstGeom prst="rect">
             <a:avLst/>
@@ -7452,7 +7452,7 @@
                 <a:ea typeface="Calibri Light" pitchFamily="34" charset="-122"/>
                 <a:cs typeface="Calibri Light" pitchFamily="34" charset="-120"/>
               </a:rPr>
-              <a:t>Paystack / Flutterwave / Moniepoint subscriptions; REST API + webhooks.</a:t>
+              <a:t>Paystack / Flutterwave / Moniepoint subscriptions; REST + webhooks.</a:t>
             </a:r>
             <a:endParaRPr lang="en-US" sz="1050" dirty="0"/>
           </a:p>
@@ -7460,7 +7460,206 @@
       </p:sp>
       <p:sp>
         <p:nvSpPr>
-          <p:cNvPr id="45" name="Text 43"/>
+          <p:cNvPr id="45" name="Shape 43"/>
+          <p:cNvSpPr/>
+          <p:nvPr/>
+        </p:nvSpPr>
+        <p:spPr>
+          <a:xfrm>
+            <a:off x="5710428" y="3493008"/>
+            <a:ext cx="2057400" cy="1097280"/>
+          </a:xfrm>
+          <a:prstGeom prst="rect">
+            <a:avLst/>
+          </a:prstGeom>
+          <a:solidFill>
+            <a:srgbClr val="FFFFFF"/>
+          </a:solidFill>
+          <a:ln w="6350">
+            <a:solidFill>
+              <a:srgbClr val="E5E7EB"/>
+            </a:solidFill>
+            <a:prstDash val="solid"/>
+          </a:ln>
+          <a:effectLst>
+            <a:outerShdw sx="100000" sy="100000" kx="0" ky="0" algn="bl" rotWithShape="0" blurRad="101600" dist="25400" dir="5400000">
+              <a:srgbClr val="1F3864">
+                <a:alpha val="6000"/>
+              </a:srgbClr>
+            </a:outerShdw>
+          </a:effectLst>
+        </p:spPr>
+      </p:sp>
+      <p:sp>
+        <p:nvSpPr>
+          <p:cNvPr id="46" name="Shape 44"/>
+          <p:cNvSpPr/>
+          <p:nvPr/>
+        </p:nvSpPr>
+        <p:spPr>
+          <a:xfrm>
+            <a:off x="5710428" y="3493008"/>
+            <a:ext cx="73152" cy="1097280"/>
+          </a:xfrm>
+          <a:prstGeom prst="rect">
+            <a:avLst/>
+          </a:prstGeom>
+          <a:solidFill>
+            <a:srgbClr val="2563EB"/>
+          </a:solidFill>
+          <a:ln w="12700">
+            <a:solidFill>
+              <a:srgbClr val="2563EB"/>
+            </a:solidFill>
+            <a:prstDash val="solid"/>
+          </a:ln>
+        </p:spPr>
+      </p:sp>
+      <p:sp>
+        <p:nvSpPr>
+          <p:cNvPr id="47" name="Shape 45"/>
+          <p:cNvSpPr/>
+          <p:nvPr/>
+        </p:nvSpPr>
+        <p:spPr>
+          <a:xfrm>
+            <a:off x="5939028" y="3694176"/>
+            <a:ext cx="502920" cy="502920"/>
+          </a:xfrm>
+          <a:prstGeom prst="ellipse">
+            <a:avLst/>
+          </a:prstGeom>
+          <a:solidFill>
+            <a:srgbClr val="2563EB"/>
+          </a:solidFill>
+          <a:ln w="12700">
+            <a:solidFill>
+              <a:srgbClr val="2563EB"/>
+            </a:solidFill>
+            <a:prstDash val="solid"/>
+          </a:ln>
+        </p:spPr>
+      </p:sp>
+      <p:sp>
+        <p:nvSpPr>
+          <p:cNvPr id="48" name="Text 46"/>
+          <p:cNvSpPr/>
+          <p:nvPr/>
+        </p:nvSpPr>
+        <p:spPr>
+          <a:xfrm>
+            <a:off x="5939028" y="3694176"/>
+            <a:ext cx="502920" cy="502920"/>
+          </a:xfrm>
+          <a:prstGeom prst="rect">
+            <a:avLst/>
+          </a:prstGeom>
+          <a:noFill/>
+          <a:ln/>
+        </p:spPr>
+        <p:txBody>
+          <a:bodyPr wrap="square" lIns="0" tIns="0" rIns="0" bIns="0" rtlCol="0" anchor="ctr"/>
+          <a:lstStyle/>
+          <a:p>
+            <a:pPr algn="ctr" indent="0" marL="0">
+              <a:buNone/>
+            </a:pPr>
+            <a:r>
+              <a:rPr lang="en-US" sz="1800" b="1" dirty="0">
+                <a:solidFill>
+                  <a:srgbClr val="FFFFFF"/>
+                </a:solidFill>
+                <a:latin typeface="Calibri" pitchFamily="34" charset="0"/>
+                <a:ea typeface="Calibri" pitchFamily="34" charset="-122"/>
+                <a:cs typeface="Calibri" pitchFamily="34" charset="-120"/>
+              </a:rPr>
+              <a:t>CR</a:t>
+            </a:r>
+            <a:endParaRPr lang="en-US" sz="1800" dirty="0"/>
+          </a:p>
+        </p:txBody>
+      </p:sp>
+      <p:sp>
+        <p:nvSpPr>
+          <p:cNvPr id="49" name="Text 47"/>
+          <p:cNvSpPr/>
+          <p:nvPr/>
+        </p:nvSpPr>
+        <p:spPr>
+          <a:xfrm>
+            <a:off x="6579108" y="3657600"/>
+            <a:ext cx="1143000" cy="320040"/>
+          </a:xfrm>
+          <a:prstGeom prst="rect">
+            <a:avLst/>
+          </a:prstGeom>
+          <a:noFill/>
+          <a:ln/>
+        </p:spPr>
+        <p:txBody>
+          <a:bodyPr wrap="square" lIns="0" tIns="0" rIns="0" bIns="0" rtlCol="0" anchor="ctr"/>
+          <a:lstStyle/>
+          <a:p>
+            <a:pPr indent="0" marL="0">
+              <a:buNone/>
+            </a:pPr>
+            <a:r>
+              <a:rPr lang="en-US" sz="1400" b="1" dirty="0">
+                <a:solidFill>
+                  <a:srgbClr val="0F172A"/>
+                </a:solidFill>
+                <a:latin typeface="Calibri" pitchFamily="34" charset="0"/>
+                <a:ea typeface="Calibri" pitchFamily="34" charset="-122"/>
+                <a:cs typeface="Calibri" pitchFamily="34" charset="-120"/>
+              </a:rPr>
+              <a:t>CRM</a:t>
+            </a:r>
+            <a:endParaRPr lang="en-US" sz="1400" dirty="0"/>
+          </a:p>
+        </p:txBody>
+      </p:sp>
+      <p:sp>
+        <p:nvSpPr>
+          <p:cNvPr id="50" name="Text 48"/>
+          <p:cNvSpPr/>
+          <p:nvPr/>
+        </p:nvSpPr>
+        <p:spPr>
+          <a:xfrm>
+            <a:off x="6579108" y="3950208"/>
+            <a:ext cx="1097280" cy="594360"/>
+          </a:xfrm>
+          <a:prstGeom prst="rect">
+            <a:avLst/>
+          </a:prstGeom>
+          <a:noFill/>
+          <a:ln/>
+        </p:spPr>
+        <p:txBody>
+          <a:bodyPr wrap="square" lIns="0" tIns="0" rIns="0" bIns="0" rtlCol="0" anchor="ctr"/>
+          <a:lstStyle/>
+          <a:p>
+            <a:pPr indent="0" marL="0">
+              <a:buNone/>
+            </a:pPr>
+            <a:r>
+              <a:rPr lang="en-US" sz="1050" dirty="0">
+                <a:solidFill>
+                  <a:srgbClr val="64748B"/>
+                </a:solidFill>
+                <a:latin typeface="Calibri Light" pitchFamily="34" charset="0"/>
+                <a:ea typeface="Calibri Light" pitchFamily="34" charset="-122"/>
+                <a:cs typeface="Calibri Light" pitchFamily="34" charset="-120"/>
+              </a:rPr>
+              <a:t>Leads, deal pipeline &amp; follow-ups — convert straight to customers.</a:t>
+            </a:r>
+            <a:endParaRPr lang="en-US" sz="1050" dirty="0"/>
+          </a:p>
+        </p:txBody>
+      </p:sp>
+      <p:sp>
+        <p:nvSpPr>
+          <p:cNvPr id="51" name="Text 49"/>
           <p:cNvSpPr/>
           <p:nvPr/>
         </p:nvSpPr>
@@ -7768,7 +7967,7 @@
                 <a:ea typeface="Calibri Light" pitchFamily="34" charset="-122"/>
                 <a:cs typeface="Calibri Light" pitchFamily="34" charset="-120"/>
               </a:rPr>
-              <a:t>The original three-tier plan is complete. Next up: CRM, scale to Postgres, and billing go-live.</a:t>
+              <a:t>The three-tier plan plus CRM is delivered. Next: scale to Postgres and billing go-live.</a:t>
             </a:r>
             <a:endParaRPr lang="en-US" sz="1300" dirty="0"/>
           </a:p>
@@ -8343,11 +8542,11 @@
             <a:avLst/>
           </a:prstGeom>
           <a:solidFill>
-            <a:srgbClr val="0EA5A4"/>
+            <a:srgbClr val="16A34A"/>
           </a:solidFill>
           <a:ln w="12700">
             <a:solidFill>
-              <a:srgbClr val="0EA5A4"/>
+              <a:srgbClr val="16A34A"/>
             </a:solidFill>
             <a:prstDash val="solid"/>
           </a:ln>
@@ -8380,13 +8579,13 @@
             <a:r>
               <a:rPr lang="en-US" sz="950" b="1" spc="200" kern="0" dirty="0">
                 <a:solidFill>
-                  <a:srgbClr val="0EA5A4"/>
+                  <a:srgbClr val="16A34A"/>
                 </a:solidFill>
                 <a:latin typeface="Calibri" pitchFamily="34" charset="0"/>
                 <a:ea typeface="Calibri" pitchFamily="34" charset="-122"/>
                 <a:cs typeface="Calibri" pitchFamily="34" charset="-120"/>
               </a:rPr>
-              <a:t>NEXT</a:t>
+              <a:t>DELIVERED</a:t>
             </a:r>
             <a:endParaRPr lang="en-US" sz="950" dirty="0"/>
           </a:p>
@@ -8464,7 +8663,7 @@
                 <a:ea typeface="Calibri Light" pitchFamily="34" charset="-122"/>
                 <a:cs typeface="Calibri Light" pitchFamily="34" charset="-120"/>
               </a:rPr>
-              <a:t>Leads, contacts, deal pipeline &amp; follow-up reminders — linked to invoices and statements.</a:t>
+              <a:t>Leads, deal pipeline &amp; follow-ups — convert straight to customers and invoices.</a:t>
             </a:r>
             <a:endParaRPr lang="en-US" sz="1000" dirty="0"/>
           </a:p>

</xml_diff>